<commit_message>
Replace المسرد with المصطلحات in md sources, generator script, and glossary PPTX
</commit_message>
<xml_diff>
--- a/output/Module02_Glossary_Quizzes.pptx
+++ b/output/Module02_Glossary_Quizzes.pptx
@@ -3143,7 +3143,7 @@
                 </a:solidFill>
                 <a:latin typeface="Calibri"/>
               </a:rPr>
-              <a:t>المسرد والاختبارات القصيرة</a:t>
+              <a:t>المصطلحات والاختبارات القصيرة</a:t>
             </a:r>
           </a:p>
           <a:p>
@@ -5958,7 +5958,7 @@
                 </a:solidFill>
                 <a:latin typeface="Calibri"/>
               </a:rPr>
-              <a:t>المسرد (1) / Glossary</a:t>
+              <a:t>المصطلحات (1) / Glossary</a:t>
             </a:r>
           </a:p>
         </p:txBody>
@@ -6817,7 +6817,7 @@
                 </a:solidFill>
                 <a:latin typeface="Calibri"/>
               </a:rPr>
-              <a:t>المسرد (2) / Glossary</a:t>
+              <a:t>المصطلحات (2) / Glossary</a:t>
             </a:r>
           </a:p>
         </p:txBody>
@@ -7676,7 +7676,7 @@
                 </a:solidFill>
                 <a:latin typeface="Calibri"/>
               </a:rPr>
-              <a:t>المسرد (3) / Glossary</a:t>
+              <a:t>المصطلحات (3) / Glossary</a:t>
             </a:r>
           </a:p>
         </p:txBody>
@@ -8535,7 +8535,7 @@
                 </a:solidFill>
                 <a:latin typeface="Calibri"/>
               </a:rPr>
-              <a:t>المسرد (4) / Glossary</a:t>
+              <a:t>المصطلحات (4) / Glossary</a:t>
             </a:r>
           </a:p>
         </p:txBody>
@@ -9394,7 +9394,7 @@
                 </a:solidFill>
                 <a:latin typeface="Calibri"/>
               </a:rPr>
-              <a:t>المسرد (5) / Glossary</a:t>
+              <a:t>المصطلحات (5) / Glossary</a:t>
             </a:r>
           </a:p>
         </p:txBody>
@@ -10253,7 +10253,7 @@
                 </a:solidFill>
                 <a:latin typeface="Calibri"/>
               </a:rPr>
-              <a:t>المسرد (6) / Glossary</a:t>
+              <a:t>المصطلحات (6) / Glossary</a:t>
             </a:r>
           </a:p>
         </p:txBody>
@@ -11112,7 +11112,7 @@
                 </a:solidFill>
                 <a:latin typeface="Calibri"/>
               </a:rPr>
-              <a:t>المسرد (7) / Glossary</a:t>
+              <a:t>المصطلحات (7) / Glossary</a:t>
             </a:r>
           </a:p>
         </p:txBody>

</xml_diff>

<commit_message>
Bidi orientation optimization + Prelude->Introduction rename
</commit_message>
<xml_diff>
--- a/output/Module02_Glossary_Quizzes.pptx
+++ b/output/Module02_Glossary_Quizzes.pptx
@@ -3150,6 +3150,8 @@
                   <a:srgbClr val="1F3B5C"/>
                 </a:solidFill>
                 <a:latin typeface="Arial"/>
+                <a:cs typeface="Arial"/>
+                <a:ea typeface="Calibri"/>
               </a:rPr>
               <a:t>المصطلحات والاختبارات القصيرة</a:t>
             </a:r>
@@ -3162,6 +3164,8 @@
                   <a:srgbClr val="666666"/>
                 </a:solidFill>
                 <a:latin typeface="Calibri"/>
+                <a:cs typeface="Arial"/>
+                <a:ea typeface="Calibri"/>
               </a:rPr>
               <a:t>Glossary &amp; Short Quizzes</a:t>
             </a:r>
@@ -3197,6 +3201,8 @@
                   <a:srgbClr val="666666"/>
                 </a:solidFill>
                 <a:latin typeface="Arial"/>
+                <a:cs typeface="Arial"/>
+                <a:ea typeface="Calibri"/>
               </a:rPr>
               <a:t>الوحدة الثانية — مادة مساندة / Module 02 — Supporting Material</a:t>
             </a:r>
@@ -3258,6 +3264,8 @@
                   <a:srgbClr val="1F3B5C"/>
                 </a:solidFill>
                 <a:latin typeface="Arial"/>
+                <a:cs typeface="Arial"/>
+                <a:ea typeface="Calibri"/>
               </a:rPr>
               <a:t>معمارية مختبر L03 / L03 Lab Architecture</a:t>
             </a:r>
@@ -3313,6 +3321,8 @@
                   <a:srgbClr val="333333"/>
                 </a:solidFill>
                 <a:latin typeface="Arial"/>
+                <a:cs typeface="Arial"/>
+                <a:ea typeface="Calibri"/>
               </a:rPr>
               <a:t>خط ETL ‏(etl_pipeline.py):‏ Bronze ‏(SQLite خام) ← Silver ‏(تنظيف + تقسيم 500/50) ← Gold ‏(ChromaDB HNSW cosine، دفعات 10)</a:t>
             </a:r>
@@ -3325,6 +3335,8 @@
                   <a:srgbClr val="666666"/>
                 </a:solidFill>
                 <a:latin typeface="Calibri"/>
+                <a:cs typeface="Arial"/>
+                <a:ea typeface="Calibri"/>
               </a:rPr>
               <a:t>ETL (etl_pipeline.py): Bronze (raw SQLite) → Silver (clean + 500/50 chunk) → Gold (ChromaDB HNSW cosine, batches of 10)</a:t>
             </a:r>
@@ -3380,6 +3392,8 @@
                   <a:srgbClr val="333333"/>
                 </a:solidFill>
                 <a:latin typeface="Arial"/>
+                <a:cs typeface="Arial"/>
+                <a:ea typeface="Calibri"/>
               </a:rPr>
               <a:t>الخلفية ‏(rag_api.py:8000):‏ استرجاع كثيف top-k=5 حد 0.2 ← توليد مؤرَّض OpenRouter free ← كاش دلالي 0.92 ← تقييم golden (12 سؤالًا)</a:t>
             </a:r>
@@ -3392,6 +3406,8 @@
                   <a:srgbClr val="666666"/>
                 </a:solidFill>
                 <a:latin typeface="Calibri"/>
+                <a:cs typeface="Arial"/>
+                <a:ea typeface="Calibri"/>
               </a:rPr>
               <a:t>Backend (rag_api.py :8000): dense top-k=5 ≥0.2 → grounded OpenRouter free → semantic cache 0.92 → golden eval (12 Q)</a:t>
             </a:r>
@@ -3447,6 +3463,8 @@
                   <a:srgbClr val="333333"/>
                 </a:solidFill>
                 <a:latin typeface="Arial"/>
+                <a:cs typeface="Arial"/>
+                <a:ea typeface="Calibri"/>
               </a:rPr>
               <a:t>الواجهة ‏(streamlit_ui.py:8501):‏ 5 تبويبات ثنائية — رفع/مستندات/استعلام/تقييم/حول — تُعيد استخدام نفس عميل Chroma مع حذف المجموعة وإعادة إنشائها</a:t>
             </a:r>
@@ -3459,6 +3477,8 @@
                   <a:srgbClr val="666666"/>
                 </a:solidFill>
                 <a:latin typeface="Calibri"/>
+                <a:cs typeface="Arial"/>
+                <a:ea typeface="Calibri"/>
               </a:rPr>
               <a:t>Frontend (streamlit_ui.py :8501): 5 bilingual tabs — upload/docs/query/eval/about — same Chroma client, drop &amp; recreate</a:t>
             </a:r>
@@ -3514,6 +3534,8 @@
                   <a:srgbClr val="333333"/>
                 </a:solidFill>
                 <a:latin typeface="Arial"/>
+                <a:cs typeface="Arial"/>
+                <a:ea typeface="Calibri"/>
               </a:rPr>
               <a:t>المخازن: l03_lab.db ‏(bronze_docs/silver_chunks)‏ + chroma_db ‏(gold_chunks بُعد 384)‏ + golden_dataset.json + env.‏ للمفتاح</a:t>
             </a:r>
@@ -3526,6 +3548,8 @@
                   <a:srgbClr val="666666"/>
                 </a:solidFill>
                 <a:latin typeface="Calibri"/>
+                <a:cs typeface="Arial"/>
+                <a:ea typeface="Calibri"/>
               </a:rPr>
               <a:t>Stores: l03_lab.db (bronze_docs/silver_chunks) + chroma_db (gold_chunks dim 384) + golden_dataset.json + .env for keys</a:t>
             </a:r>
@@ -3561,6 +3585,8 @@
                   <a:srgbClr val="666666"/>
                 </a:solidFill>
                 <a:latin typeface="Arial"/>
+                <a:cs typeface="Arial"/>
+                <a:ea typeface="Calibri"/>
               </a:rPr>
               <a:t>التفاصيل الكاملة في l03_lab/ARCHITECTURE.md.</a:t>
             </a:r>
@@ -3568,6 +3594,11 @@
           <a:p>
             <a:pPr algn="r" rtl="0"/>
             <a:r>
+              <a:rPr>
+                <a:latin typeface="Calibri"/>
+                <a:cs typeface="Arial"/>
+                <a:ea typeface="Calibri"/>
+              </a:rPr>
               <a:t>Full detail in l03_lab/ARCHITECTURE.md.</a:t>
             </a:r>
           </a:p>
@@ -3628,6 +3659,8 @@
                   <a:srgbClr val="1F3B5C"/>
                 </a:solidFill>
                 <a:latin typeface="Arial"/>
+                <a:cs typeface="Arial"/>
+                <a:ea typeface="Calibri"/>
               </a:rPr>
               <a:t>تشغيل مختبر L03 / Running the L03 Lab</a:t>
             </a:r>
@@ -3663,6 +3696,8 @@
                   <a:srgbClr val="333333"/>
                 </a:solidFill>
                 <a:latin typeface="Calibri"/>
+                <a:cs typeface="Arial"/>
+                <a:ea typeface="Calibri"/>
               </a:rPr>
               <a:t>cd l03_lab  +  source .venv/bin/activate</a:t>
             </a:r>
@@ -3698,6 +3733,8 @@
                   <a:srgbClr val="333333"/>
                 </a:solidFill>
                 <a:latin typeface="Calibri"/>
+                <a:cs typeface="Arial"/>
+                <a:ea typeface="Calibri"/>
               </a:rPr>
               <a:t>OMP_NUM_THREADS=1 MKL_NUM_THREADS=1 TOKENIZERS_PARALLELISM=false  python -u etl_pipeline.py</a:t>
             </a:r>
@@ -3733,6 +3770,8 @@
                   <a:srgbClr val="333333"/>
                 </a:solidFill>
                 <a:latin typeface="Calibri"/>
+                <a:cs typeface="Arial"/>
+                <a:ea typeface="Calibri"/>
               </a:rPr>
               <a:t>./run_ui.sh   →   http://localhost:8501</a:t>
             </a:r>
@@ -3768,6 +3807,8 @@
                   <a:srgbClr val="333333"/>
                 </a:solidFill>
                 <a:latin typeface="Calibri"/>
+                <a:cs typeface="Arial"/>
+                <a:ea typeface="Calibri"/>
               </a:rPr>
               <a:t>uvicorn rag_api:app --reload   →   http://localhost:8000/docs</a:t>
             </a:r>
@@ -3803,6 +3844,8 @@
                   <a:srgbClr val="333333"/>
                 </a:solidFill>
                 <a:latin typeface="Calibri"/>
+                <a:cs typeface="Arial"/>
+                <a:ea typeface="Calibri"/>
               </a:rPr>
               <a:t>python rag_api.py evaluate</a:t>
             </a:r>
@@ -3838,13 +3881,20 @@
                   <a:srgbClr val="666666"/>
                 </a:solidFill>
                 <a:latin typeface="Arial"/>
+                <a:cs typeface="Arial"/>
+                <a:ea typeface="Calibri"/>
               </a:rPr>
               <a:t>دائمًا من داخل الـ venv — التشغيل الخارجي يسبب segfault.</a:t>
             </a:r>
           </a:p>
           <a:p>
-            <a:pPr algn="r" rtl="0"/>
-            <a:r>
+            <a:pPr algn="l" rtl="0"/>
+            <a:r>
+              <a:rPr>
+                <a:latin typeface="Calibri"/>
+                <a:cs typeface="Arial"/>
+                <a:ea typeface="Calibri"/>
+              </a:rPr>
               <a:t>Always inside the venv — outside env segfaults.</a:t>
             </a:r>
           </a:p>
@@ -3905,6 +3955,8 @@
                   <a:srgbClr val="1F3B5C"/>
                 </a:solidFill>
                 <a:latin typeface="Arial"/>
+                <a:cs typeface="Arial"/>
+                <a:ea typeface="Calibri"/>
               </a:rPr>
               <a:t>دروس الجمود / Freeze Lessons (مطبَّقة في الكود)</a:t>
             </a:r>
@@ -3960,6 +4012,8 @@
                   <a:srgbClr val="333333"/>
                 </a:solidFill>
                 <a:latin typeface="Arial"/>
+                <a:cs typeface="Arial"/>
+                <a:ea typeface="Calibri"/>
               </a:rPr>
               <a:t>عميل ChromaDB واحد فقط — عميل ثانٍ = قفل SQLite وتجمّد بعد [Silver]</a:t>
             </a:r>
@@ -3972,6 +4026,8 @@
                   <a:srgbClr val="666666"/>
                 </a:solidFill>
                 <a:latin typeface="Calibri"/>
+                <a:cs typeface="Arial"/>
+                <a:ea typeface="Calibri"/>
               </a:rPr>
               <a:t>Single ChromaDB client only — a 2nd client = SQLite lock, freeze after [Silver]</a:t>
             </a:r>
@@ -4027,6 +4083,8 @@
                   <a:srgbClr val="333333"/>
                 </a:solidFill>
                 <a:latin typeface="Arial"/>
+                <a:cs typeface="Arial"/>
+                <a:ea typeface="Calibri"/>
               </a:rPr>
               <a:t>حذف المجموعة وإعادة إنشائها بدل delete+add على مقطع HNSW مستخدَم</a:t>
             </a:r>
@@ -4039,6 +4097,8 @@
                   <a:srgbClr val="666666"/>
                 </a:solidFill>
                 <a:latin typeface="Calibri"/>
+                <a:cs typeface="Arial"/>
+                <a:ea typeface="Calibri"/>
               </a:rPr>
               <a:t>Drop &amp; recreate collection instead of delete+add on a used HNSW segment</a:t>
             </a:r>
@@ -4094,6 +4154,8 @@
                   <a:srgbClr val="333333"/>
                 </a:solidFill>
                 <a:latin typeface="Arial"/>
+                <a:cs typeface="Arial"/>
+                <a:ea typeface="Calibri"/>
               </a:rPr>
               <a:t>ترميز صريح بدفعات 10 + سجلات encode/inserting/done + شريط تقدم</a:t>
             </a:r>
@@ -4106,6 +4168,8 @@
                   <a:srgbClr val="666666"/>
                 </a:solidFill>
                 <a:latin typeface="Calibri"/>
+                <a:cs typeface="Arial"/>
+                <a:ea typeface="Calibri"/>
               </a:rPr>
               <a:t>Explicit encoding in batches of 10 + encode/inserting/done logs + progress bar</a:t>
             </a:r>
@@ -4161,6 +4225,8 @@
                   <a:srgbClr val="333333"/>
                 </a:solidFill>
                 <a:latin typeface="Arial"/>
+                <a:cs typeface="Arial"/>
+                <a:ea typeface="Calibri"/>
               </a:rPr>
               <a:t>macOS: ‏OMP/MKL=1‏ + ‏TOKENIZERS_PARALLELISM=false‏ قبل استيراد onnx + ‏python -u‏ + اسم ‏gold_chunks‏ موحّد</a:t>
             </a:r>
@@ -4173,6 +4239,8 @@
                   <a:srgbClr val="666666"/>
                 </a:solidFill>
                 <a:latin typeface="Calibri"/>
+                <a:cs typeface="Arial"/>
+                <a:ea typeface="Calibri"/>
               </a:rPr>
               <a:t>macOS: OMP/MKL=1 + TOKENIZERS_PARALLELISM=false before onnx import + python -u + one gold_chunks name</a:t>
             </a:r>
@@ -4208,6 +4276,8 @@
                   <a:srgbClr val="666666"/>
                 </a:solidFill>
                 <a:latin typeface="Arial"/>
+                <a:cs typeface="Arial"/>
+                <a:ea typeface="Calibri"/>
               </a:rPr>
               <a:t>أول تشغيل لـ Gold يُنزّل all-MiniLM-L6-v2 ‏(~80MB)‏ لمرة واحدة.</a:t>
             </a:r>
@@ -4215,6 +4285,11 @@
           <a:p>
             <a:pPr algn="r" rtl="0"/>
             <a:r>
+              <a:rPr>
+                <a:latin typeface="Calibri"/>
+                <a:cs typeface="Arial"/>
+                <a:ea typeface="Calibri"/>
+              </a:rPr>
               <a:t>First Gold run downloads all-MiniLM-L6-v2 (~80MB) once.</a:t>
             </a:r>
           </a:p>
@@ -4275,6 +4350,8 @@
                   <a:srgbClr val="1F3B5C"/>
                 </a:solidFill>
                 <a:latin typeface="Arial"/>
+                <a:cs typeface="Arial"/>
+                <a:ea typeface="Calibri"/>
               </a:rPr>
               <a:t>V06 — أساسيات البيانات / Data Fundamentals — أسئلة / Questions</a:t>
             </a:r>
@@ -4310,6 +4387,8 @@
                   <a:srgbClr val="333333"/>
                 </a:solidFill>
                 <a:latin typeface="Arial"/>
+                <a:cs typeface="Arial"/>
+                <a:ea typeface="Calibri"/>
               </a:rPr>
               <a:t>س: ما الفرق الجوهري بين ETL وELT؟</a:t>
             </a:r>
@@ -4322,6 +4401,8 @@
                   <a:srgbClr val="666666"/>
                 </a:solidFill>
                 <a:latin typeface="Calibri"/>
+                <a:cs typeface="Arial"/>
+                <a:ea typeface="Calibri"/>
               </a:rPr>
               <a:t>Q: What is the key difference between ETL and ELT?</a:t>
             </a:r>
@@ -4357,6 +4438,8 @@
                   <a:srgbClr val="333333"/>
                 </a:solidFill>
                 <a:latin typeface="Arial"/>
+                <a:cs typeface="Arial"/>
+                <a:ea typeface="Calibri"/>
               </a:rPr>
               <a:t>س: أين تُستخدم طبقة Gold في المعمارية المتدرِّجة؟</a:t>
             </a:r>
@@ -4369,6 +4452,8 @@
                   <a:srgbClr val="666666"/>
                 </a:solidFill>
                 <a:latin typeface="Calibri"/>
+                <a:cs typeface="Arial"/>
+                <a:ea typeface="Calibri"/>
               </a:rPr>
               <a:t>Q: Where is the Gold layer used in the Medallion architecture?</a:t>
             </a:r>
@@ -4404,6 +4489,8 @@
                   <a:srgbClr val="333333"/>
                 </a:solidFill>
                 <a:latin typeface="Arial"/>
+                <a:cs typeface="Arial"/>
+                <a:ea typeface="Calibri"/>
               </a:rPr>
               <a:t>س: أي نمط يناسب مؤسسة كبيرة بفرق مستقلة وملكية لامركزية؟</a:t>
             </a:r>
@@ -4416,6 +4503,8 @@
                   <a:srgbClr val="666666"/>
                 </a:solidFill>
                 <a:latin typeface="Calibri"/>
+                <a:cs typeface="Arial"/>
+                <a:ea typeface="Calibri"/>
               </a:rPr>
               <a:t>Q: Which pattern suits a large organization with independent, decentralized teams?</a:t>
             </a:r>
@@ -4451,6 +4540,8 @@
                   <a:srgbClr val="333333"/>
                 </a:solidFill>
                 <a:latin typeface="Arial"/>
+                <a:cs typeface="Arial"/>
+                <a:ea typeface="Calibri"/>
               </a:rPr>
               <a:t>س: ما التنسيق الأنسب للتحليلات عالية الأداء ولماذا؟</a:t>
             </a:r>
@@ -4463,6 +4554,8 @@
                   <a:srgbClr val="666666"/>
                 </a:solidFill>
                 <a:latin typeface="Calibri"/>
+                <a:cs typeface="Arial"/>
+                <a:ea typeface="Calibri"/>
               </a:rPr>
               <a:t>Q: Which format suits high-performance analytics and why?</a:t>
             </a:r>
@@ -4524,6 +4617,8 @@
                   <a:srgbClr val="1F3B5C"/>
                 </a:solidFill>
                 <a:latin typeface="Arial"/>
+                <a:cs typeface="Arial"/>
+                <a:ea typeface="Calibri"/>
               </a:rPr>
               <a:t>V06 — أساسيات البيانات / Data Fundamentals — إجابات / Answers</a:t>
             </a:r>
@@ -4559,6 +4654,8 @@
                   <a:srgbClr val="1F4E79"/>
                 </a:solidFill>
                 <a:latin typeface="Arial"/>
+                <a:cs typeface="Arial"/>
+                <a:ea typeface="Calibri"/>
               </a:rPr>
               <a:t>✅ ETL يحوّل قبل التحميل؛ ELT يحمّل أولاً ثم يحوّل داخل المنصة الهدف.</a:t>
             </a:r>
@@ -4571,6 +4668,8 @@
                   <a:srgbClr val="666666"/>
                 </a:solidFill>
                 <a:latin typeface="Calibri"/>
+                <a:cs typeface="Arial"/>
+                <a:ea typeface="Calibri"/>
               </a:rPr>
               <a:t>✅ ETL transforms before loading; ELT loads first and transforms inside the target platform.</a:t>
             </a:r>
@@ -4606,6 +4705,8 @@
                   <a:srgbClr val="1F4E79"/>
                 </a:solidFill>
                 <a:latin typeface="Arial"/>
+                <a:cs typeface="Arial"/>
+                <a:ea typeface="Calibri"/>
               </a:rPr>
               <a:t>✅ تجميعات على مستوى الأعمال جاهزة للتحليل.</a:t>
             </a:r>
@@ -4618,6 +4719,8 @@
                   <a:srgbClr val="666666"/>
                 </a:solidFill>
                 <a:latin typeface="Calibri"/>
+                <a:cs typeface="Arial"/>
+                <a:ea typeface="Calibri"/>
               </a:rPr>
               <a:t>✅ Business-level aggregates that are analytics-ready.</a:t>
             </a:r>
@@ -4653,6 +4756,8 @@
                   <a:srgbClr val="1F4E79"/>
                 </a:solidFill>
                 <a:latin typeface="Arial"/>
+                <a:cs typeface="Arial"/>
+                <a:ea typeface="Calibri"/>
               </a:rPr>
               <a:t>✅ شبكة البيانات Data Mesh.</a:t>
             </a:r>
@@ -4665,6 +4770,8 @@
                   <a:srgbClr val="666666"/>
                 </a:solidFill>
                 <a:latin typeface="Calibri"/>
+                <a:cs typeface="Arial"/>
+                <a:ea typeface="Calibri"/>
               </a:rPr>
               <a:t>✅ Data mesh.</a:t>
             </a:r>
@@ -4700,6 +4807,8 @@
                   <a:srgbClr val="1F4E79"/>
                 </a:solidFill>
                 <a:latin typeface="Arial"/>
+                <a:cs typeface="Arial"/>
+                <a:ea typeface="Calibri"/>
               </a:rPr>
               <a:t>✅ Parquet — تنسيق عمودي يقلل الحجم ويسرّع القراءة.</a:t>
             </a:r>
@@ -4712,6 +4821,8 @@
                   <a:srgbClr val="666666"/>
                 </a:solidFill>
                 <a:latin typeface="Calibri"/>
+                <a:cs typeface="Arial"/>
+                <a:ea typeface="Calibri"/>
               </a:rPr>
               <a:t>✅ Parquet — columnar, smaller and faster for analytical reads.</a:t>
             </a:r>
@@ -4773,6 +4884,8 @@
                   <a:srgbClr val="1F3B5C"/>
                 </a:solidFill>
                 <a:latin typeface="Arial"/>
+                <a:cs typeface="Arial"/>
+                <a:ea typeface="Calibri"/>
               </a:rPr>
               <a:t>V07 — المستودعات والبحيرات ومعمارية Lakehouse / Warehouses, Data Lakes &amp; Lakehouse — أسئلة / Questions</a:t>
             </a:r>
@@ -4808,6 +4921,8 @@
                   <a:srgbClr val="333333"/>
                 </a:solidFill>
                 <a:latin typeface="Arial"/>
+                <a:cs typeface="Arial"/>
+                <a:ea typeface="Calibri"/>
               </a:rPr>
               <a:t>س: ما معنى «مخطط عند القراءة»؟</a:t>
             </a:r>
@@ -4820,6 +4935,8 @@
                   <a:srgbClr val="666666"/>
                 </a:solidFill>
                 <a:latin typeface="Calibri"/>
+                <a:cs typeface="Arial"/>
+                <a:ea typeface="Calibri"/>
               </a:rPr>
               <a:t>Q: What does 'schema-on-read' mean?</a:t>
             </a:r>
@@ -4855,6 +4972,8 @@
                   <a:srgbClr val="333333"/>
                 </a:solidFill>
                 <a:latin typeface="Arial"/>
+                <a:cs typeface="Arial"/>
+                <a:ea typeface="Calibri"/>
               </a:rPr>
               <a:t>س: ما مكونات عقد البيانات الثلاثة؟</a:t>
             </a:r>
@@ -4867,6 +4986,8 @@
                   <a:srgbClr val="666666"/>
                 </a:solidFill>
                 <a:latin typeface="Calibri"/>
+                <a:cs typeface="Arial"/>
+                <a:ea typeface="Calibri"/>
               </a:rPr>
               <a:t>Q: What are the three components of a data contract?</a:t>
             </a:r>
@@ -4902,6 +5023,8 @@
                   <a:srgbClr val="333333"/>
                 </a:solidFill>
                 <a:latin typeface="Arial"/>
+                <a:cs typeface="Arial"/>
+                <a:ea typeface="Calibri"/>
               </a:rPr>
               <a:t>س: ماذا يضيف Lakehouse عن البحيرة المجردة؟</a:t>
             </a:r>
@@ -4914,6 +5037,8 @@
                   <a:srgbClr val="666666"/>
                 </a:solidFill>
                 <a:latin typeface="Calibri"/>
+                <a:cs typeface="Arial"/>
+                <a:ea typeface="Calibri"/>
               </a:rPr>
               <a:t>Q: What does a lakehouse add over a raw lake?</a:t>
             </a:r>
@@ -4975,6 +5100,8 @@
                   <a:srgbClr val="1F3B5C"/>
                 </a:solidFill>
                 <a:latin typeface="Arial"/>
+                <a:cs typeface="Arial"/>
+                <a:ea typeface="Calibri"/>
               </a:rPr>
               <a:t>V07 — المستودعات والبحيرات ومعمارية Lakehouse / Warehouses, Data Lakes &amp; Lakehouse — إجابات / Answers</a:t>
             </a:r>
@@ -5010,6 +5137,8 @@
                   <a:srgbClr val="1F4E79"/>
                 </a:solidFill>
                 <a:latin typeface="Arial"/>
+                <a:cs typeface="Arial"/>
+                <a:ea typeface="Calibri"/>
               </a:rPr>
               <a:t>✅ لا يُفرض المخطط عند الكتابة بل عند القراءة — سمة البحيرات.</a:t>
             </a:r>
@@ -5022,6 +5151,8 @@
                   <a:srgbClr val="666666"/>
                 </a:solidFill>
                 <a:latin typeface="Calibri"/>
+                <a:cs typeface="Arial"/>
+                <a:ea typeface="Calibri"/>
               </a:rPr>
               <a:t>✅ Schema is enforced at read time, not write time — a lake trait.</a:t>
             </a:r>
@@ -5057,6 +5188,8 @@
                   <a:srgbClr val="1F4E79"/>
                 </a:solidFill>
                 <a:latin typeface="Arial"/>
+                <a:cs typeface="Arial"/>
+                <a:ea typeface="Calibri"/>
               </a:rPr>
               <a:t>✅ المخطط، الأمان، مستوى الخدمة SLA.</a:t>
             </a:r>
@@ -5069,6 +5202,8 @@
                   <a:srgbClr val="666666"/>
                 </a:solidFill>
                 <a:latin typeface="Calibri"/>
+                <a:cs typeface="Arial"/>
+                <a:ea typeface="Calibri"/>
               </a:rPr>
               <a:t>✅ Schema, security, and SLA.</a:t>
             </a:r>
@@ -5104,6 +5239,8 @@
                   <a:srgbClr val="1F4E79"/>
                 </a:solidFill>
                 <a:latin typeface="Arial"/>
+                <a:cs typeface="Arial"/>
+                <a:ea typeface="Calibri"/>
               </a:rPr>
               <a:t>✅ معاملات ACID وأداء SQL وحوكمة.</a:t>
             </a:r>
@@ -5116,6 +5253,8 @@
                   <a:srgbClr val="666666"/>
                 </a:solidFill>
                 <a:latin typeface="Calibri"/>
+                <a:cs typeface="Arial"/>
+                <a:ea typeface="Calibri"/>
               </a:rPr>
               <a:t>✅ ACID transactions, SQL performance, and governance.</a:t>
             </a:r>
@@ -5177,6 +5316,8 @@
                   <a:srgbClr val="1F3B5C"/>
                 </a:solidFill>
                 <a:latin typeface="Arial"/>
+                <a:cs typeface="Arial"/>
+                <a:ea typeface="Calibri"/>
               </a:rPr>
               <a:t>V08 — هندسة الخصائص ومخازنها / Feature Engineering &amp; Feature Stores — أسئلة / Questions</a:t>
             </a:r>
@@ -5212,6 +5353,8 @@
                   <a:srgbClr val="333333"/>
                 </a:solidFill>
                 <a:latin typeface="Arial"/>
+                <a:cs typeface="Arial"/>
+                <a:ea typeface="Calibri"/>
               </a:rPr>
               <a:t>س: ما المشكلة التي يحلها مخزن الخصائص؟</a:t>
             </a:r>
@@ -5224,6 +5367,8 @@
                   <a:srgbClr val="666666"/>
                 </a:solidFill>
                 <a:latin typeface="Calibri"/>
+                <a:cs typeface="Arial"/>
+                <a:ea typeface="Calibri"/>
               </a:rPr>
               <a:t>Q: What problem does a feature store solve?</a:t>
             </a:r>
@@ -5259,6 +5404,8 @@
                   <a:srgbClr val="333333"/>
                 </a:solidFill>
                 <a:latin typeface="Arial"/>
+                <a:cs typeface="Arial"/>
+                <a:ea typeface="Calibri"/>
               </a:rPr>
               <a:t>س: فرّق بين المخزن Offline وOnline.</a:t>
             </a:r>
@@ -5271,6 +5418,8 @@
                   <a:srgbClr val="666666"/>
                 </a:solidFill>
                 <a:latin typeface="Calibri"/>
+                <a:cs typeface="Arial"/>
+                <a:ea typeface="Calibri"/>
               </a:rPr>
               <a:t>Q: Differentiate offline vs online stores.</a:t>
             </a:r>
@@ -5306,6 +5455,8 @@
                   <a:srgbClr val="333333"/>
                 </a:solidFill>
                 <a:latin typeface="Arial"/>
+                <a:cs typeface="Arial"/>
+                <a:ea typeface="Calibri"/>
               </a:rPr>
               <a:t>س: اذكر أداتين لمخازن الخصائص.</a:t>
             </a:r>
@@ -5318,6 +5469,8 @@
                   <a:srgbClr val="666666"/>
                 </a:solidFill>
                 <a:latin typeface="Calibri"/>
+                <a:cs typeface="Arial"/>
+                <a:ea typeface="Calibri"/>
               </a:rPr>
               <a:t>Q: Name two feature-store tools.</a:t>
             </a:r>
@@ -5379,6 +5532,8 @@
                   <a:srgbClr val="1F3B5C"/>
                 </a:solidFill>
                 <a:latin typeface="Arial"/>
+                <a:cs typeface="Arial"/>
+                <a:ea typeface="Calibri"/>
               </a:rPr>
               <a:t>V08 — هندسة الخصائص ومخازنها / Feature Engineering &amp; Feature Stores — إجابات / Answers</a:t>
             </a:r>
@@ -5414,6 +5569,8 @@
                   <a:srgbClr val="1F4E79"/>
                 </a:solidFill>
                 <a:latin typeface="Arial"/>
+                <a:cs typeface="Arial"/>
+                <a:ea typeface="Calibri"/>
               </a:rPr>
               <a:t>✅ انحراف الميزات بين التدريب والخدمة وتكرار العمل.</a:t>
             </a:r>
@@ -5426,6 +5583,8 @@
                   <a:srgbClr val="666666"/>
                 </a:solidFill>
                 <a:latin typeface="Calibri"/>
+                <a:cs typeface="Arial"/>
+                <a:ea typeface="Calibri"/>
               </a:rPr>
               <a:t>✅ Feature skew between training/serving and duplicated work.</a:t>
             </a:r>
@@ -5461,6 +5620,8 @@
                   <a:srgbClr val="1F4E79"/>
                 </a:solidFill>
                 <a:latin typeface="Arial"/>
+                <a:cs typeface="Arial"/>
+                <a:ea typeface="Calibri"/>
               </a:rPr>
               <a:t>✅ Offline للتدريب التاريخي؛ Online لخدمة فورية منخفضة الكمون.</a:t>
             </a:r>
@@ -5473,6 +5634,8 @@
                   <a:srgbClr val="666666"/>
                 </a:solidFill>
                 <a:latin typeface="Calibri"/>
+                <a:cs typeface="Arial"/>
+                <a:ea typeface="Calibri"/>
               </a:rPr>
               <a:t>✅ Offline for historical training; online for low-latency serving.</a:t>
             </a:r>
@@ -5508,6 +5671,8 @@
                   <a:srgbClr val="1F4E79"/>
                 </a:solidFill>
                 <a:latin typeface="Arial"/>
+                <a:cs typeface="Arial"/>
+                <a:ea typeface="Calibri"/>
               </a:rPr>
               <a:t>✅ Feast وHopsworks (أو Tecton).</a:t>
             </a:r>
@@ -5520,6 +5685,8 @@
                   <a:srgbClr val="666666"/>
                 </a:solidFill>
                 <a:latin typeface="Calibri"/>
+                <a:cs typeface="Arial"/>
+                <a:ea typeface="Calibri"/>
               </a:rPr>
               <a:t>✅ Feast and Hopsworks (or Tecton).</a:t>
             </a:r>
@@ -5581,6 +5748,8 @@
                   <a:srgbClr val="1F3B5C"/>
                 </a:solidFill>
                 <a:latin typeface="Arial"/>
+                <a:cs typeface="Arial"/>
+                <a:ea typeface="Calibri"/>
               </a:rPr>
               <a:t>V09 — قواعد البيانات المتجهية + RAG التطبيقي / Vector Databases + Applied RAG — أسئلة / Questions</a:t>
             </a:r>
@@ -5616,6 +5785,8 @@
                   <a:srgbClr val="333333"/>
                 </a:solidFill>
                 <a:latin typeface="Arial"/>
+                <a:cs typeface="Arial"/>
+                <a:ea typeface="Calibri"/>
               </a:rPr>
               <a:t>س: ما استراتيجية التقسيم الموصى بها افتراضيًا؟</a:t>
             </a:r>
@@ -5628,6 +5799,8 @@
                   <a:srgbClr val="666666"/>
                 </a:solidFill>
                 <a:latin typeface="Calibri"/>
+                <a:cs typeface="Arial"/>
+                <a:ea typeface="Calibri"/>
               </a:rPr>
               <a:t>Q: Which chunking strategy is the recommended default?</a:t>
             </a:r>
@@ -5663,6 +5836,8 @@
                   <a:srgbClr val="333333"/>
                 </a:solidFill>
                 <a:latin typeface="Arial"/>
+                <a:cs typeface="Arial"/>
+                <a:ea typeface="Calibri"/>
               </a:rPr>
               <a:t>س: لماذا نجمع البحث الكثيف مع BM25؟</a:t>
             </a:r>
@@ -5675,6 +5850,8 @@
                   <a:srgbClr val="666666"/>
                 </a:solidFill>
                 <a:latin typeface="Calibri"/>
+                <a:cs typeface="Arial"/>
+                <a:ea typeface="Calibri"/>
               </a:rPr>
               <a:t>Q: Why combine dense search with BM25?</a:t>
             </a:r>
@@ -5710,6 +5887,8 @@
                   <a:srgbClr val="333333"/>
                 </a:solidFill>
                 <a:latin typeface="Arial"/>
+                <a:cs typeface="Arial"/>
+                <a:ea typeface="Calibri"/>
               </a:rPr>
               <a:t>س: ما مكونات مثلث تقييم RAG الثلاثة؟</a:t>
             </a:r>
@@ -5722,6 +5901,8 @@
                   <a:srgbClr val="666666"/>
                 </a:solidFill>
                 <a:latin typeface="Calibri"/>
+                <a:cs typeface="Arial"/>
+                <a:ea typeface="Calibri"/>
               </a:rPr>
               <a:t>Q: Name the three parts of the RAG evaluation triad.</a:t>
             </a:r>
@@ -5757,6 +5938,8 @@
                   <a:srgbClr val="333333"/>
                 </a:solidFill>
                 <a:latin typeface="Arial"/>
+                <a:cs typeface="Arial"/>
+                <a:ea typeface="Calibri"/>
               </a:rPr>
               <a:t>س: ما وظيفة إعادة الترتيب Cross-encoder؟</a:t>
             </a:r>
@@ -5769,6 +5952,8 @@
                   <a:srgbClr val="666666"/>
                 </a:solidFill>
                 <a:latin typeface="Calibri"/>
+                <a:cs typeface="Arial"/>
+                <a:ea typeface="Calibri"/>
               </a:rPr>
               <a:t>Q: What does cross-encoder reranking do?</a:t>
             </a:r>
@@ -5804,6 +5989,8 @@
                   <a:srgbClr val="333333"/>
                 </a:solidFill>
                 <a:latin typeface="Arial"/>
+                <a:cs typeface="Arial"/>
+                <a:ea typeface="Calibri"/>
               </a:rPr>
               <a:t>س: كيف يقلل التخزين الدلالي المؤقت التكلفة؟</a:t>
             </a:r>
@@ -5816,6 +6003,8 @@
                   <a:srgbClr val="666666"/>
                 </a:solidFill>
                 <a:latin typeface="Calibri"/>
+                <a:cs typeface="Arial"/>
+                <a:ea typeface="Calibri"/>
               </a:rPr>
               <a:t>Q: How does semantic caching cut cost?</a:t>
             </a:r>
@@ -5877,6 +6066,8 @@
                   <a:srgbClr val="1F3B5C"/>
                 </a:solidFill>
                 <a:latin typeface="Arial"/>
+                <a:cs typeface="Arial"/>
+                <a:ea typeface="Calibri"/>
               </a:rPr>
               <a:t>المصطلحات (1) / Glossary</a:t>
             </a:r>
@@ -5912,6 +6103,8 @@
                   <a:srgbClr val="333333"/>
                 </a:solidFill>
                 <a:latin typeface="Arial"/>
+                <a:cs typeface="Arial"/>
+                <a:ea typeface="Calibri"/>
               </a:rPr>
               <a:t>خط أنابيب البيانات</a:t>
             </a:r>
@@ -5947,6 +6140,8 @@
                   <a:srgbClr val="666666"/>
                 </a:solidFill>
                 <a:latin typeface="Calibri"/>
+                <a:cs typeface="Arial"/>
+                <a:ea typeface="Calibri"/>
               </a:rPr>
               <a:t>Data Pipeline</a:t>
             </a:r>
@@ -6026,6 +6221,8 @@
                   <a:srgbClr val="333333"/>
                 </a:solidFill>
                 <a:latin typeface="Arial"/>
+                <a:cs typeface="Arial"/>
+                <a:ea typeface="Calibri"/>
               </a:rPr>
               <a:t>الاستخراج والتحويل والتحميل</a:t>
             </a:r>
@@ -6061,6 +6258,8 @@
                   <a:srgbClr val="666666"/>
                 </a:solidFill>
                 <a:latin typeface="Calibri"/>
+                <a:cs typeface="Arial"/>
+                <a:ea typeface="Calibri"/>
               </a:rPr>
               <a:t>ETL (Extract, Transform, Load)</a:t>
             </a:r>
@@ -6140,6 +6339,8 @@
                   <a:srgbClr val="333333"/>
                 </a:solidFill>
                 <a:latin typeface="Arial"/>
+                <a:cs typeface="Arial"/>
+                <a:ea typeface="Calibri"/>
               </a:rPr>
               <a:t>الاستخراج والتحميل والتحويل</a:t>
             </a:r>
@@ -6175,6 +6376,8 @@
                   <a:srgbClr val="666666"/>
                 </a:solidFill>
                 <a:latin typeface="Calibri"/>
+                <a:cs typeface="Arial"/>
+                <a:ea typeface="Calibri"/>
               </a:rPr>
               <a:t>ELT</a:t>
             </a:r>
@@ -6254,6 +6457,8 @@
                   <a:srgbClr val="333333"/>
                 </a:solidFill>
                 <a:latin typeface="Arial"/>
+                <a:cs typeface="Arial"/>
+                <a:ea typeface="Calibri"/>
               </a:rPr>
               <a:t>المعمارية المتدرِّجة</a:t>
             </a:r>
@@ -6289,6 +6494,8 @@
                   <a:srgbClr val="666666"/>
                 </a:solidFill>
                 <a:latin typeface="Calibri"/>
+                <a:cs typeface="Arial"/>
+                <a:ea typeface="Calibri"/>
               </a:rPr>
               <a:t>Medallion Architecture</a:t>
             </a:r>
@@ -6368,6 +6575,8 @@
                   <a:srgbClr val="333333"/>
                 </a:solidFill>
                 <a:latin typeface="Arial"/>
+                <a:cs typeface="Arial"/>
+                <a:ea typeface="Calibri"/>
               </a:rPr>
               <a:t>مستودع البيانات</a:t>
             </a:r>
@@ -6403,6 +6612,8 @@
                   <a:srgbClr val="666666"/>
                 </a:solidFill>
                 <a:latin typeface="Calibri"/>
+                <a:cs typeface="Arial"/>
+                <a:ea typeface="Calibri"/>
               </a:rPr>
               <a:t>Data Warehouse</a:t>
             </a:r>
@@ -6482,6 +6693,8 @@
                   <a:srgbClr val="333333"/>
                 </a:solidFill>
                 <a:latin typeface="Arial"/>
+                <a:cs typeface="Arial"/>
+                <a:ea typeface="Calibri"/>
               </a:rPr>
               <a:t>بحيرة البيانات</a:t>
             </a:r>
@@ -6517,6 +6730,8 @@
                   <a:srgbClr val="666666"/>
                 </a:solidFill>
                 <a:latin typeface="Calibri"/>
+                <a:cs typeface="Arial"/>
+                <a:ea typeface="Calibri"/>
               </a:rPr>
               <a:t>Data Lake</a:t>
             </a:r>
@@ -6622,6 +6837,8 @@
                   <a:srgbClr val="1F3B5C"/>
                 </a:solidFill>
                 <a:latin typeface="Arial"/>
+                <a:cs typeface="Arial"/>
+                <a:ea typeface="Calibri"/>
               </a:rPr>
               <a:t>V09 — قواعد البيانات المتجهية + RAG التطبيقي / Vector Databases + Applied RAG — إجابات / Answers</a:t>
             </a:r>
@@ -6657,6 +6874,8 @@
                   <a:srgbClr val="1F4E79"/>
                 </a:solidFill>
                 <a:latin typeface="Arial"/>
+                <a:cs typeface="Arial"/>
+                <a:ea typeface="Calibri"/>
               </a:rPr>
               <a:t>✅ التقسيم التكراري Recursive Chunking.</a:t>
             </a:r>
@@ -6669,6 +6888,8 @@
                   <a:srgbClr val="666666"/>
                 </a:solidFill>
                 <a:latin typeface="Calibri"/>
+                <a:cs typeface="Arial"/>
+                <a:ea typeface="Calibri"/>
               </a:rPr>
               <a:t>✅ Recursive chunking.</a:t>
             </a:r>
@@ -6704,6 +6925,8 @@
                   <a:srgbClr val="1F4E79"/>
                 </a:solidFill>
                 <a:latin typeface="Arial"/>
+                <a:cs typeface="Arial"/>
+                <a:ea typeface="Calibri"/>
               </a:rPr>
               <a:t>✅ الكثيف يفهم المعنى وBM25 يطابق الكلمات النادرة حرفيًا.</a:t>
             </a:r>
@@ -6716,6 +6939,8 @@
                   <a:srgbClr val="666666"/>
                 </a:solidFill>
                 <a:latin typeface="Calibri"/>
+                <a:cs typeface="Arial"/>
+                <a:ea typeface="Calibri"/>
               </a:rPr>
               <a:t>✅ Dense captures meaning; BM25 matches rare exact keywords.</a:t>
             </a:r>
@@ -6751,6 +6976,8 @@
                   <a:srgbClr val="1F4E79"/>
                 </a:solidFill>
                 <a:latin typeface="Arial"/>
+                <a:cs typeface="Arial"/>
+                <a:ea typeface="Calibri"/>
               </a:rPr>
               <a:t>✅ الوفاء، ملاءمة الإجابة، دقة السياق.</a:t>
             </a:r>
@@ -6763,6 +6990,8 @@
                   <a:srgbClr val="666666"/>
                 </a:solidFill>
                 <a:latin typeface="Calibri"/>
+                <a:cs typeface="Arial"/>
+                <a:ea typeface="Calibri"/>
               </a:rPr>
               <a:t>✅ Faithfulness, answer relevancy, context precision.</a:t>
             </a:r>
@@ -6798,6 +7027,8 @@
                   <a:srgbClr val="1F4E79"/>
                 </a:solidFill>
                 <a:latin typeface="Arial"/>
+                <a:cs typeface="Arial"/>
+                <a:ea typeface="Calibri"/>
               </a:rPr>
               <a:t>✅ يعيد ترتيب المرشحين بنموذج أدق لرفع ملاءمة النتائج.</a:t>
             </a:r>
@@ -6810,6 +7041,8 @@
                   <a:srgbClr val="666666"/>
                 </a:solidFill>
                 <a:latin typeface="Calibri"/>
+                <a:cs typeface="Arial"/>
+                <a:ea typeface="Calibri"/>
               </a:rPr>
               <a:t>✅ Re-scores candidates with a more accurate model.</a:t>
             </a:r>
@@ -6845,6 +7078,8 @@
                   <a:srgbClr val="1F4E79"/>
                 </a:solidFill>
                 <a:latin typeface="Arial"/>
+                <a:cs typeface="Arial"/>
+                <a:ea typeface="Calibri"/>
               </a:rPr>
               <a:t>✅ يعيد استخدام إجابات الأسئلة المشابهة بدل استدعاء النموذج كل مرة.</a:t>
             </a:r>
@@ -6857,6 +7092,8 @@
                   <a:srgbClr val="666666"/>
                 </a:solidFill>
                 <a:latin typeface="Calibri"/>
+                <a:cs typeface="Arial"/>
+                <a:ea typeface="Calibri"/>
               </a:rPr>
               <a:t>✅ Reuses answers for similar questions.</a:t>
             </a:r>
@@ -6918,6 +7155,8 @@
                   <a:srgbClr val="1F3B5C"/>
                 </a:solidFill>
                 <a:latin typeface="Arial"/>
+                <a:cs typeface="Arial"/>
+                <a:ea typeface="Calibri"/>
               </a:rPr>
               <a:t>V10 — تصنيف البيانات على نطاق واسع / Labeling at Scale — أسئلة / Questions</a:t>
             </a:r>
@@ -6953,6 +7192,8 @@
                   <a:srgbClr val="333333"/>
                 </a:solidFill>
                 <a:latin typeface="Arial"/>
+                <a:cs typeface="Arial"/>
+                <a:ea typeface="Calibri"/>
               </a:rPr>
               <a:t>س: لماذا لا نعتمد تصنيفات LLM مباشرة دون مراجعة؟</a:t>
             </a:r>
@@ -6965,6 +7206,8 @@
                   <a:srgbClr val="666666"/>
                 </a:solidFill>
                 <a:latin typeface="Calibri"/>
+                <a:cs typeface="Arial"/>
+                <a:ea typeface="Calibri"/>
               </a:rPr>
               <a:t>Q: Why not accept LLM labels directly without review?</a:t>
             </a:r>
@@ -7000,6 +7243,8 @@
                   <a:srgbClr val="333333"/>
                 </a:solidFill>
                 <a:latin typeface="Arial"/>
+                <a:cs typeface="Arial"/>
+                <a:ea typeface="Calibri"/>
               </a:rPr>
               <a:t>س: أي أداة تناسب مشاريع الرؤية الحاسوبية؟</a:t>
             </a:r>
@@ -7012,6 +7257,8 @@
                   <a:srgbClr val="666666"/>
                 </a:solidFill>
                 <a:latin typeface="Calibri"/>
+                <a:cs typeface="Arial"/>
+                <a:ea typeface="Calibri"/>
               </a:rPr>
               <a:t>Q: Which tool fits computer-vision projects?</a:t>
             </a:r>
@@ -7073,6 +7320,8 @@
                   <a:srgbClr val="1F3B5C"/>
                 </a:solidFill>
                 <a:latin typeface="Arial"/>
+                <a:cs typeface="Arial"/>
+                <a:ea typeface="Calibri"/>
               </a:rPr>
               <a:t>V10 — تصنيف البيانات على نطاق واسع / Labeling at Scale — إجابات / Answers</a:t>
             </a:r>
@@ -7108,6 +7357,8 @@
                   <a:srgbClr val="1F4E79"/>
                 </a:solidFill>
                 <a:latin typeface="Arial"/>
+                <a:cs typeface="Arial"/>
+                <a:ea typeface="Calibri"/>
               </a:rPr>
               <a:t>✅ لأن النموذج قد يخطئ أو يتحيز — التحقق البشري يضمن الجودة.</a:t>
             </a:r>
@@ -7120,6 +7371,8 @@
                   <a:srgbClr val="666666"/>
                 </a:solidFill>
                 <a:latin typeface="Calibri"/>
+                <a:cs typeface="Arial"/>
+                <a:ea typeface="Calibri"/>
               </a:rPr>
               <a:t>✅ The model can err or be biased — human validation guarantees quality.</a:t>
             </a:r>
@@ -7148,13 +7401,15 @@
           </a:bodyPr>
           <a:lstStyle/>
           <a:p>
-            <a:pPr algn="r" rtl="1"/>
+            <a:pPr algn="r" rtl="0"/>
             <a:r>
               <a:rPr sz="1400" b="1">
                 <a:solidFill>
                   <a:srgbClr val="1F4E79"/>
                 </a:solidFill>
-                <a:latin typeface="Arial"/>
+                <a:latin typeface="Calibri"/>
+                <a:cs typeface="Arial"/>
+                <a:ea typeface="Calibri"/>
               </a:rPr>
               <a:t>✅ Roboflow.</a:t>
             </a:r>
@@ -7167,6 +7422,8 @@
                   <a:srgbClr val="666666"/>
                 </a:solidFill>
                 <a:latin typeface="Calibri"/>
+                <a:cs typeface="Arial"/>
+                <a:ea typeface="Calibri"/>
               </a:rPr>
               <a:t>✅ Roboflow.</a:t>
             </a:r>
@@ -7228,6 +7485,8 @@
                   <a:srgbClr val="1F3B5C"/>
                 </a:solidFill>
                 <a:latin typeface="Arial"/>
+                <a:cs typeface="Arial"/>
+                <a:ea typeface="Calibri"/>
               </a:rPr>
               <a:t>V11 — حوكمة البيانات وسلسلة العهدة والفهرسة / Data Governance, Lineage &amp; Cataloging — أسئلة / Questions</a:t>
             </a:r>
@@ -7263,6 +7522,8 @@
                   <a:srgbClr val="333333"/>
                 </a:solidFill>
                 <a:latin typeface="Arial"/>
+                <a:cs typeface="Arial"/>
+                <a:ea typeface="Calibri"/>
               </a:rPr>
               <a:t>س: ما وظيفة بوابة AI الموحدة (AI Gateway)؟</a:t>
             </a:r>
@@ -7275,6 +7536,8 @@
                   <a:srgbClr val="666666"/>
                 </a:solidFill>
                 <a:latin typeface="Calibri"/>
+                <a:cs typeface="Arial"/>
+                <a:ea typeface="Calibri"/>
               </a:rPr>
               <a:t>Q: What does a unified AI gateway do?</a:t>
             </a:r>
@@ -7310,6 +7573,8 @@
                   <a:srgbClr val="333333"/>
                 </a:solidFill>
                 <a:latin typeface="Arial"/>
+                <a:cs typeface="Arial"/>
+                <a:ea typeface="Calibri"/>
               </a:rPr>
               <a:t>س: لماذا نحتاج قاعدة تدقيق لنماذج LLM؟</a:t>
             </a:r>
@@ -7322,6 +7587,8 @@
                   <a:srgbClr val="666666"/>
                 </a:solidFill>
                 <a:latin typeface="Calibri"/>
+                <a:cs typeface="Arial"/>
+                <a:ea typeface="Calibri"/>
               </a:rPr>
               <a:t>Q: Why keep an LLM audit database?</a:t>
             </a:r>
@@ -7357,6 +7624,8 @@
                   <a:srgbClr val="333333"/>
                 </a:solidFill>
                 <a:latin typeface="Arial"/>
+                <a:cs typeface="Arial"/>
+                <a:ea typeface="Calibri"/>
               </a:rPr>
               <a:t>س: ما دور CI/CD في حوكمة GenAI؟</a:t>
             </a:r>
@@ -7369,6 +7638,8 @@
                   <a:srgbClr val="666666"/>
                 </a:solidFill>
                 <a:latin typeface="Calibri"/>
+                <a:cs typeface="Arial"/>
+                <a:ea typeface="Calibri"/>
               </a:rPr>
               <a:t>Q: What is CI/CD's role in GenAI governance?</a:t>
             </a:r>
@@ -7430,6 +7701,8 @@
                   <a:srgbClr val="1F3B5C"/>
                 </a:solidFill>
                 <a:latin typeface="Arial"/>
+                <a:cs typeface="Arial"/>
+                <a:ea typeface="Calibri"/>
               </a:rPr>
               <a:t>V11 — حوكمة البيانات وسلسلة العهدة والفهرسة / Data Governance, Lineage &amp; Cataloging — إجابات / Answers</a:t>
             </a:r>
@@ -7465,6 +7738,8 @@
                   <a:srgbClr val="1F4E79"/>
                 </a:solidFill>
                 <a:latin typeface="Arial"/>
+                <a:cs typeface="Arial"/>
+                <a:ea typeface="Calibri"/>
               </a:rPr>
               <a:t>✅ نقطة دخول موحدة تفرض المصادقة والحدود والتسجيل على كل الاستدعاءات.</a:t>
             </a:r>
@@ -7477,6 +7752,8 @@
                   <a:srgbClr val="666666"/>
                 </a:solidFill>
                 <a:latin typeface="Calibri"/>
+                <a:cs typeface="Arial"/>
+                <a:ea typeface="Calibri"/>
               </a:rPr>
               <a:t>✅ A single entry point enforcing auth, limits, and logging for all calls.</a:t>
             </a:r>
@@ -7512,6 +7789,8 @@
                   <a:srgbClr val="1F4E79"/>
                 </a:solidFill>
                 <a:latin typeface="Arial"/>
+                <a:cs typeface="Arial"/>
+                <a:ea typeface="Calibri"/>
               </a:rPr>
               <a:t>✅ لتتبع الموجِّهات والإجابات والامتثال والتحقيق في الحوادث.</a:t>
             </a:r>
@@ -7524,6 +7803,8 @@
                   <a:srgbClr val="666666"/>
                 </a:solidFill>
                 <a:latin typeface="Calibri"/>
+                <a:cs typeface="Arial"/>
+                <a:ea typeface="Calibri"/>
               </a:rPr>
               <a:t>✅ To trace prompts/answers for compliance and investigation.</a:t>
             </a:r>
@@ -7559,6 +7840,8 @@
                   <a:srgbClr val="1F4E79"/>
                 </a:solidFill>
                 <a:latin typeface="Arial"/>
+                <a:cs typeface="Arial"/>
+                <a:ea typeface="Calibri"/>
               </a:rPr>
               <a:t>✅ بوابات تحكم وموافقات مرحلية آلية قبل الإنتاج.</a:t>
             </a:r>
@@ -7571,6 +7854,8 @@
                   <a:srgbClr val="666666"/>
                 </a:solidFill>
                 <a:latin typeface="Calibri"/>
+                <a:cs typeface="Arial"/>
+                <a:ea typeface="Calibri"/>
               </a:rPr>
               <a:t>✅ Automated control gates and approvals before production.</a:t>
             </a:r>
@@ -7632,8 +7917,10 @@
                   <a:srgbClr val="1F3B5C"/>
                 </a:solidFill>
                 <a:latin typeface="Arial"/>
-              </a:rPr>
-              <a:t>V12 — أساسيات MLOps + تمهيد للمختبر / MLOps Fundamentals + Lab Prelude — أسئلة / Questions</a:t>
+                <a:cs typeface="Arial"/>
+                <a:ea typeface="Calibri"/>
+              </a:rPr>
+              <a:t>V12 — أساسيات MLOps + تمهيد للمختبر / MLOps Fundamentals + Lab Introduction — أسئلة / Questions</a:t>
             </a:r>
           </a:p>
         </p:txBody>
@@ -7667,6 +7954,8 @@
                   <a:srgbClr val="333333"/>
                 </a:solidFill>
                 <a:latin typeface="Arial"/>
+                <a:cs typeface="Arial"/>
+                <a:ea typeface="Calibri"/>
               </a:rPr>
               <a:t>س: فرّق بين AI Agent وAgentic AI.</a:t>
             </a:r>
@@ -7679,6 +7968,8 @@
                   <a:srgbClr val="666666"/>
                 </a:solidFill>
                 <a:latin typeface="Calibri"/>
+                <a:cs typeface="Arial"/>
+                <a:ea typeface="Calibri"/>
               </a:rPr>
               <a:t>Q: Differentiate an AI agent from agentic AI.</a:t>
             </a:r>
@@ -7714,6 +8005,8 @@
                   <a:srgbClr val="333333"/>
                 </a:solidFill>
                 <a:latin typeface="Arial"/>
+                <a:cs typeface="Arial"/>
+                <a:ea typeface="Calibri"/>
               </a:rPr>
               <a:t>س: ما أرخص: تضمين أم توليد؟</a:t>
             </a:r>
@@ -7726,6 +8019,8 @@
                   <a:srgbClr val="666666"/>
                 </a:solidFill>
                 <a:latin typeface="Calibri"/>
+                <a:cs typeface="Arial"/>
+                <a:ea typeface="Calibri"/>
               </a:rPr>
               <a:t>Q: Which is cheaper: embedding or generation?</a:t>
             </a:r>
@@ -7761,6 +8056,8 @@
                   <a:srgbClr val="333333"/>
                 </a:solidFill>
                 <a:latin typeface="Arial"/>
+                <a:cs typeface="Arial"/>
+                <a:ea typeface="Calibri"/>
               </a:rPr>
               <a:t>س: ما أدوات تتبع التجارب وإصدارات البيانات؟</a:t>
             </a:r>
@@ -7773,6 +8070,8 @@
                   <a:srgbClr val="666666"/>
                 </a:solidFill>
                 <a:latin typeface="Calibri"/>
+                <a:cs typeface="Arial"/>
+                <a:ea typeface="Calibri"/>
               </a:rPr>
               <a:t>Q: Which tools track experiments and version data?</a:t>
             </a:r>
@@ -7834,8 +8133,10 @@
                   <a:srgbClr val="1F3B5C"/>
                 </a:solidFill>
                 <a:latin typeface="Arial"/>
-              </a:rPr>
-              <a:t>V12 — أساسيات MLOps + تمهيد للمختبر / MLOps Fundamentals + Lab Prelude — إجابات / Answers</a:t>
+                <a:cs typeface="Arial"/>
+                <a:ea typeface="Calibri"/>
+              </a:rPr>
+              <a:t>V12 — أساسيات MLOps + تمهيد للمختبر / MLOps Fundamentals + Lab Introduction — إجابات / Answers</a:t>
             </a:r>
           </a:p>
         </p:txBody>
@@ -7869,6 +8170,8 @@
                   <a:srgbClr val="1F4E79"/>
                 </a:solidFill>
                 <a:latin typeface="Arial"/>
+                <a:cs typeface="Arial"/>
+                <a:ea typeface="Calibri"/>
               </a:rPr>
               <a:t>✅ الوكيل يستجيب ويستدعي أدوات؛ الوكيلي يخطط ذاتيًا وينفذ خطوات متعددة ويتكيف.</a:t>
             </a:r>
@@ -7881,6 +8184,8 @@
                   <a:srgbClr val="666666"/>
                 </a:solidFill>
                 <a:latin typeface="Calibri"/>
+                <a:cs typeface="Arial"/>
+                <a:ea typeface="Calibri"/>
               </a:rPr>
               <a:t>✅ An agent responds and calls tools; agentic AI self-plans multi-step execution.</a:t>
             </a:r>
@@ -7916,6 +8221,8 @@
                   <a:srgbClr val="1F4E79"/>
                 </a:solidFill>
                 <a:latin typeface="Arial"/>
+                <a:cs typeface="Arial"/>
+                <a:ea typeface="Calibri"/>
               </a:rPr>
               <a:t>✅ التضمين — أقل بتكلفة مرتبة كاملة.</a:t>
             </a:r>
@@ -7928,6 +8235,8 @@
                   <a:srgbClr val="666666"/>
                 </a:solidFill>
                 <a:latin typeface="Calibri"/>
+                <a:cs typeface="Arial"/>
+                <a:ea typeface="Calibri"/>
               </a:rPr>
               <a:t>✅ Embedding — roughly an order of magnitude cheaper.</a:t>
             </a:r>
@@ -7963,6 +8272,8 @@
                   <a:srgbClr val="1F4E79"/>
                 </a:solidFill>
                 <a:latin typeface="Arial"/>
+                <a:cs typeface="Arial"/>
+                <a:ea typeface="Calibri"/>
               </a:rPr>
               <a:t>✅ MLflow للتتبع وDVC لإصدارات البيانات.</a:t>
             </a:r>
@@ -7975,6 +8286,8 @@
                   <a:srgbClr val="666666"/>
                 </a:solidFill>
                 <a:latin typeface="Calibri"/>
+                <a:cs typeface="Arial"/>
+                <a:ea typeface="Calibri"/>
               </a:rPr>
               <a:t>✅ MLflow for tracking, DVC for data versioning.</a:t>
             </a:r>
@@ -8036,6 +8349,8 @@
                   <a:srgbClr val="1F3B5C"/>
                 </a:solidFill>
                 <a:latin typeface="Arial"/>
+                <a:cs typeface="Arial"/>
+                <a:ea typeface="Calibri"/>
               </a:rPr>
               <a:t>المصطلحات (2) / Glossary</a:t>
             </a:r>
@@ -8071,6 +8386,8 @@
                   <a:srgbClr val="333333"/>
                 </a:solidFill>
                 <a:latin typeface="Arial"/>
+                <a:cs typeface="Arial"/>
+                <a:ea typeface="Calibri"/>
               </a:rPr>
               <a:t>معمارية بحيرة البيانات الموحدة</a:t>
             </a:r>
@@ -8106,6 +8423,8 @@
                   <a:srgbClr val="666666"/>
                 </a:solidFill>
                 <a:latin typeface="Calibri"/>
+                <a:cs typeface="Arial"/>
+                <a:ea typeface="Calibri"/>
               </a:rPr>
               <a:t>Lakehouse</a:t>
             </a:r>
@@ -8185,6 +8504,8 @@
                   <a:srgbClr val="333333"/>
                 </a:solidFill>
                 <a:latin typeface="Arial"/>
+                <a:cs typeface="Arial"/>
+                <a:ea typeface="Calibri"/>
               </a:rPr>
               <a:t>شبكة البيانات</a:t>
             </a:r>
@@ -8220,6 +8541,8 @@
                   <a:srgbClr val="666666"/>
                 </a:solidFill>
                 <a:latin typeface="Calibri"/>
+                <a:cs typeface="Arial"/>
+                <a:ea typeface="Calibri"/>
               </a:rPr>
               <a:t>Data Mesh</a:t>
             </a:r>
@@ -8299,6 +8622,8 @@
                   <a:srgbClr val="333333"/>
                 </a:solidFill>
                 <a:latin typeface="Arial"/>
+                <a:cs typeface="Arial"/>
+                <a:ea typeface="Calibri"/>
               </a:rPr>
               <a:t>منتج البيانات</a:t>
             </a:r>
@@ -8334,6 +8659,8 @@
                   <a:srgbClr val="666666"/>
                 </a:solidFill>
                 <a:latin typeface="Calibri"/>
+                <a:cs typeface="Arial"/>
+                <a:ea typeface="Calibri"/>
               </a:rPr>
               <a:t>Data Product</a:t>
             </a:r>
@@ -8413,6 +8740,8 @@
                   <a:srgbClr val="333333"/>
                 </a:solidFill>
                 <a:latin typeface="Arial"/>
+                <a:cs typeface="Arial"/>
+                <a:ea typeface="Calibri"/>
               </a:rPr>
               <a:t>عقد البيانات</a:t>
             </a:r>
@@ -8448,6 +8777,8 @@
                   <a:srgbClr val="666666"/>
                 </a:solidFill>
                 <a:latin typeface="Calibri"/>
+                <a:cs typeface="Arial"/>
+                <a:ea typeface="Calibri"/>
               </a:rPr>
               <a:t>Data Contract</a:t>
             </a:r>
@@ -8527,6 +8858,8 @@
                   <a:srgbClr val="333333"/>
                 </a:solidFill>
                 <a:latin typeface="Arial"/>
+                <a:cs typeface="Arial"/>
+                <a:ea typeface="Calibri"/>
               </a:rPr>
               <a:t>سلسلة العهدة</a:t>
             </a:r>
@@ -8562,6 +8895,8 @@
                   <a:srgbClr val="666666"/>
                 </a:solidFill>
                 <a:latin typeface="Calibri"/>
+                <a:cs typeface="Arial"/>
+                <a:ea typeface="Calibri"/>
               </a:rPr>
               <a:t>Data Lineage</a:t>
             </a:r>
@@ -8641,6 +8976,8 @@
                   <a:srgbClr val="333333"/>
                 </a:solidFill>
                 <a:latin typeface="Arial"/>
+                <a:cs typeface="Arial"/>
+                <a:ea typeface="Calibri"/>
               </a:rPr>
               <a:t>فهرس البيانات / الكتالوج</a:t>
             </a:r>
@@ -8676,6 +9013,8 @@
                   <a:srgbClr val="666666"/>
                 </a:solidFill>
                 <a:latin typeface="Calibri"/>
+                <a:cs typeface="Arial"/>
+                <a:ea typeface="Calibri"/>
               </a:rPr>
               <a:t>Data Catalog</a:t>
             </a:r>
@@ -8781,6 +9120,8 @@
                   <a:srgbClr val="1F3B5C"/>
                 </a:solidFill>
                 <a:latin typeface="Arial"/>
+                <a:cs typeface="Arial"/>
+                <a:ea typeface="Calibri"/>
               </a:rPr>
               <a:t>المصطلحات (3) / Glossary</a:t>
             </a:r>
@@ -8816,6 +9157,8 @@
                   <a:srgbClr val="333333"/>
                 </a:solidFill>
                 <a:latin typeface="Arial"/>
+                <a:cs typeface="Arial"/>
+                <a:ea typeface="Calibri"/>
               </a:rPr>
               <a:t>هندسة الخصائص</a:t>
             </a:r>
@@ -8851,6 +9194,8 @@
                   <a:srgbClr val="666666"/>
                 </a:solidFill>
                 <a:latin typeface="Calibri"/>
+                <a:cs typeface="Arial"/>
+                <a:ea typeface="Calibri"/>
               </a:rPr>
               <a:t>Feature Engineering</a:t>
             </a:r>
@@ -8930,6 +9275,8 @@
                   <a:srgbClr val="333333"/>
                 </a:solidFill>
                 <a:latin typeface="Arial"/>
+                <a:cs typeface="Arial"/>
+                <a:ea typeface="Calibri"/>
               </a:rPr>
               <a:t>مخزن الخصائص</a:t>
             </a:r>
@@ -8965,6 +9312,8 @@
                   <a:srgbClr val="666666"/>
                 </a:solidFill>
                 <a:latin typeface="Calibri"/>
+                <a:cs typeface="Arial"/>
+                <a:ea typeface="Calibri"/>
               </a:rPr>
               <a:t>Feature Store</a:t>
             </a:r>
@@ -9044,6 +9393,8 @@
                   <a:srgbClr val="333333"/>
                 </a:solidFill>
                 <a:latin typeface="Arial"/>
+                <a:cs typeface="Arial"/>
+                <a:ea typeface="Calibri"/>
               </a:rPr>
               <a:t>انحراف الميزات</a:t>
             </a:r>
@@ -9079,6 +9430,8 @@
                   <a:srgbClr val="666666"/>
                 </a:solidFill>
                 <a:latin typeface="Calibri"/>
+                <a:cs typeface="Arial"/>
+                <a:ea typeface="Calibri"/>
               </a:rPr>
               <a:t>Feature Skew</a:t>
             </a:r>
@@ -9158,6 +9511,8 @@
                   <a:srgbClr val="333333"/>
                 </a:solidFill>
                 <a:latin typeface="Arial"/>
+                <a:cs typeface="Arial"/>
+                <a:ea typeface="Calibri"/>
               </a:rPr>
               <a:t>قاعدة البيانات المتجهية</a:t>
             </a:r>
@@ -9193,6 +9548,8 @@
                   <a:srgbClr val="666666"/>
                 </a:solidFill>
                 <a:latin typeface="Calibri"/>
+                <a:cs typeface="Arial"/>
+                <a:ea typeface="Calibri"/>
               </a:rPr>
               <a:t>Vector Database</a:t>
             </a:r>
@@ -9272,6 +9629,8 @@
                   <a:srgbClr val="333333"/>
                 </a:solidFill>
                 <a:latin typeface="Arial"/>
+                <a:cs typeface="Arial"/>
+                <a:ea typeface="Calibri"/>
               </a:rPr>
               <a:t>التمثيل المتجهي</a:t>
             </a:r>
@@ -9307,6 +9666,8 @@
                   <a:srgbClr val="666666"/>
                 </a:solidFill>
                 <a:latin typeface="Calibri"/>
+                <a:cs typeface="Arial"/>
+                <a:ea typeface="Calibri"/>
               </a:rPr>
               <a:t>Embedding</a:t>
             </a:r>
@@ -9386,6 +9747,8 @@
                   <a:srgbClr val="333333"/>
                 </a:solidFill>
                 <a:latin typeface="Arial"/>
+                <a:cs typeface="Arial"/>
+                <a:ea typeface="Calibri"/>
               </a:rPr>
               <a:t>البحث التقريبي لأقرب الجيران</a:t>
             </a:r>
@@ -9421,6 +9784,8 @@
                   <a:srgbClr val="666666"/>
                 </a:solidFill>
                 <a:latin typeface="Calibri"/>
+                <a:cs typeface="Arial"/>
+                <a:ea typeface="Calibri"/>
               </a:rPr>
               <a:t>ANN (Approximate Nearest Neighbor)</a:t>
             </a:r>
@@ -9526,6 +9891,8 @@
                   <a:srgbClr val="1F3B5C"/>
                 </a:solidFill>
                 <a:latin typeface="Arial"/>
+                <a:cs typeface="Arial"/>
+                <a:ea typeface="Calibri"/>
               </a:rPr>
               <a:t>المصطلحات (4) / Glossary</a:t>
             </a:r>
@@ -9561,6 +9928,8 @@
                   <a:srgbClr val="333333"/>
                 </a:solidFill>
                 <a:latin typeface="Arial"/>
+                <a:cs typeface="Arial"/>
+                <a:ea typeface="Calibri"/>
               </a:rPr>
               <a:t>فهرس HNSW</a:t>
             </a:r>
@@ -9596,6 +9965,8 @@
                   <a:srgbClr val="666666"/>
                 </a:solidFill>
                 <a:latin typeface="Calibri"/>
+                <a:cs typeface="Arial"/>
+                <a:ea typeface="Calibri"/>
               </a:rPr>
               <a:t>HNSW Index</a:t>
             </a:r>
@@ -9675,6 +10046,8 @@
                   <a:srgbClr val="333333"/>
                 </a:solidFill>
                 <a:latin typeface="Arial"/>
+                <a:cs typeface="Arial"/>
+                <a:ea typeface="Calibri"/>
               </a:rPr>
               <a:t>التقسيم التكراري</a:t>
             </a:r>
@@ -9710,6 +10083,8 @@
                   <a:srgbClr val="666666"/>
                 </a:solidFill>
                 <a:latin typeface="Calibri"/>
+                <a:cs typeface="Arial"/>
+                <a:ea typeface="Calibri"/>
               </a:rPr>
               <a:t>Recursive Chunking</a:t>
             </a:r>
@@ -9789,6 +10164,8 @@
                   <a:srgbClr val="333333"/>
                 </a:solidFill>
                 <a:latin typeface="Arial"/>
+                <a:cs typeface="Arial"/>
+                <a:ea typeface="Calibri"/>
               </a:rPr>
               <a:t>التقسيم الدلالي</a:t>
             </a:r>
@@ -9824,6 +10201,8 @@
                   <a:srgbClr val="666666"/>
                 </a:solidFill>
                 <a:latin typeface="Calibri"/>
+                <a:cs typeface="Arial"/>
+                <a:ea typeface="Calibri"/>
               </a:rPr>
               <a:t>Semantic Chunking</a:t>
             </a:r>
@@ -9903,6 +10282,8 @@
                   <a:srgbClr val="333333"/>
                 </a:solidFill>
                 <a:latin typeface="Arial"/>
+                <a:cs typeface="Arial"/>
+                <a:ea typeface="Calibri"/>
               </a:rPr>
               <a:t>البحث الهجين</a:t>
             </a:r>
@@ -9938,6 +10319,8 @@
                   <a:srgbClr val="666666"/>
                 </a:solidFill>
                 <a:latin typeface="Calibri"/>
+                <a:cs typeface="Arial"/>
+                <a:ea typeface="Calibri"/>
               </a:rPr>
               <a:t>Hybrid Search</a:t>
             </a:r>
@@ -10017,6 +10400,8 @@
                   <a:srgbClr val="333333"/>
                 </a:solidFill>
                 <a:latin typeface="Arial"/>
+                <a:cs typeface="Arial"/>
+                <a:ea typeface="Calibri"/>
               </a:rPr>
               <a:t>البحث الكثيف / المتناثر</a:t>
             </a:r>
@@ -10052,6 +10437,8 @@
                   <a:srgbClr val="666666"/>
                 </a:solidFill>
                 <a:latin typeface="Calibri"/>
+                <a:cs typeface="Arial"/>
+                <a:ea typeface="Calibri"/>
               </a:rPr>
               <a:t>Dense / Sparse Retrieval</a:t>
             </a:r>
@@ -10131,6 +10518,8 @@
                   <a:srgbClr val="333333"/>
                 </a:solidFill>
                 <a:latin typeface="Arial"/>
+                <a:cs typeface="Arial"/>
+                <a:ea typeface="Calibri"/>
               </a:rPr>
               <a:t>إعادة الترتيب</a:t>
             </a:r>
@@ -10166,6 +10555,8 @@
                   <a:srgbClr val="666666"/>
                 </a:solidFill>
                 <a:latin typeface="Calibri"/>
+                <a:cs typeface="Arial"/>
+                <a:ea typeface="Calibri"/>
               </a:rPr>
               <a:t>Reranking</a:t>
             </a:r>
@@ -10271,6 +10662,8 @@
                   <a:srgbClr val="1F3B5C"/>
                 </a:solidFill>
                 <a:latin typeface="Arial"/>
+                <a:cs typeface="Arial"/>
+                <a:ea typeface="Calibri"/>
               </a:rPr>
               <a:t>المصطلحات (5) / Glossary</a:t>
             </a:r>
@@ -10306,6 +10699,8 @@
                   <a:srgbClr val="333333"/>
                 </a:solidFill>
                 <a:latin typeface="Arial"/>
+                <a:cs typeface="Arial"/>
+                <a:ea typeface="Calibri"/>
               </a:rPr>
               <a:t>الموجِّه المقيَّد بالمصادر</a:t>
             </a:r>
@@ -10341,6 +10736,8 @@
                   <a:srgbClr val="666666"/>
                 </a:solidFill>
                 <a:latin typeface="Calibri"/>
+                <a:cs typeface="Arial"/>
+                <a:ea typeface="Calibri"/>
               </a:rPr>
               <a:t>Grounded Prompting</a:t>
             </a:r>
@@ -10420,6 +10817,8 @@
                   <a:srgbClr val="333333"/>
                 </a:solidFill>
                 <a:latin typeface="Arial"/>
+                <a:cs typeface="Arial"/>
+                <a:ea typeface="Calibri"/>
               </a:rPr>
               <a:t>التوليد المعزَّز بالاسترجاع</a:t>
             </a:r>
@@ -10455,6 +10854,8 @@
                   <a:srgbClr val="666666"/>
                 </a:solidFill>
                 <a:latin typeface="Calibri"/>
+                <a:cs typeface="Arial"/>
+                <a:ea typeface="Calibri"/>
               </a:rPr>
               <a:t>RAG (Retrieval-Augmented Generation)</a:t>
             </a:r>
@@ -10534,6 +10935,8 @@
                   <a:srgbClr val="333333"/>
                 </a:solidFill>
                 <a:latin typeface="Arial"/>
+                <a:cs typeface="Arial"/>
+                <a:ea typeface="Calibri"/>
               </a:rPr>
               <a:t>RAG الوكيلي</a:t>
             </a:r>
@@ -10569,6 +10972,8 @@
                   <a:srgbClr val="666666"/>
                 </a:solidFill>
                 <a:latin typeface="Calibri"/>
+                <a:cs typeface="Arial"/>
+                <a:ea typeface="Calibri"/>
               </a:rPr>
               <a:t>Agentic RAG</a:t>
             </a:r>
@@ -10648,6 +11053,8 @@
                   <a:srgbClr val="333333"/>
                 </a:solidFill>
                 <a:latin typeface="Arial"/>
+                <a:cs typeface="Arial"/>
+                <a:ea typeface="Calibri"/>
               </a:rPr>
               <a:t>الوفاء بالمصدر</a:t>
             </a:r>
@@ -10683,6 +11090,8 @@
                   <a:srgbClr val="666666"/>
                 </a:solidFill>
                 <a:latin typeface="Calibri"/>
+                <a:cs typeface="Arial"/>
+                <a:ea typeface="Calibri"/>
               </a:rPr>
               <a:t>Faithfulness</a:t>
             </a:r>
@@ -10762,6 +11171,8 @@
                   <a:srgbClr val="333333"/>
                 </a:solidFill>
                 <a:latin typeface="Arial"/>
+                <a:cs typeface="Arial"/>
+                <a:ea typeface="Calibri"/>
               </a:rPr>
               <a:t>ملاءمة الإجابة</a:t>
             </a:r>
@@ -10797,6 +11208,8 @@
                   <a:srgbClr val="666666"/>
                 </a:solidFill>
                 <a:latin typeface="Calibri"/>
+                <a:cs typeface="Arial"/>
+                <a:ea typeface="Calibri"/>
               </a:rPr>
               <a:t>Answer Relevancy</a:t>
             </a:r>
@@ -10876,6 +11289,8 @@
                   <a:srgbClr val="333333"/>
                 </a:solidFill>
                 <a:latin typeface="Arial"/>
+                <a:cs typeface="Arial"/>
+                <a:ea typeface="Calibri"/>
               </a:rPr>
               <a:t>دقة السياق</a:t>
             </a:r>
@@ -10911,6 +11326,8 @@
                   <a:srgbClr val="666666"/>
                 </a:solidFill>
                 <a:latin typeface="Calibri"/>
+                <a:cs typeface="Arial"/>
+                <a:ea typeface="Calibri"/>
               </a:rPr>
               <a:t>Context Precision</a:t>
             </a:r>
@@ -11016,6 +11433,8 @@
                   <a:srgbClr val="1F3B5C"/>
                 </a:solidFill>
                 <a:latin typeface="Arial"/>
+                <a:cs typeface="Arial"/>
+                <a:ea typeface="Calibri"/>
               </a:rPr>
               <a:t>المصطلحات (6) / Glossary</a:t>
             </a:r>
@@ -11051,6 +11470,8 @@
                   <a:srgbClr val="333333"/>
                 </a:solidFill>
                 <a:latin typeface="Arial"/>
+                <a:cs typeface="Arial"/>
+                <a:ea typeface="Calibri"/>
               </a:rPr>
               <a:t>التخزين الدلالي المؤقت</a:t>
             </a:r>
@@ -11086,6 +11507,8 @@
                   <a:srgbClr val="666666"/>
                 </a:solidFill>
                 <a:latin typeface="Calibri"/>
+                <a:cs typeface="Arial"/>
+                <a:ea typeface="Calibri"/>
               </a:rPr>
               <a:t>Semantic Caching</a:t>
             </a:r>
@@ -11165,6 +11588,8 @@
                   <a:srgbClr val="333333"/>
                 </a:solidFill>
                 <a:latin typeface="Arial"/>
+                <a:cs typeface="Arial"/>
+                <a:ea typeface="Calibri"/>
               </a:rPr>
               <a:t>عميل ChromaDB واحد (لا قفل SQLite)</a:t>
             </a:r>
@@ -11200,6 +11625,8 @@
                   <a:srgbClr val="666666"/>
                 </a:solidFill>
                 <a:latin typeface="Calibri"/>
+                <a:cs typeface="Arial"/>
+                <a:ea typeface="Calibri"/>
               </a:rPr>
               <a:t>Single ChromaDB client (no SQLite lock)</a:t>
             </a:r>
@@ -11279,6 +11706,8 @@
                   <a:srgbClr val="333333"/>
                 </a:solidFill>
                 <a:latin typeface="Arial"/>
+                <a:cs typeface="Arial"/>
+                <a:ea typeface="Calibri"/>
               </a:rPr>
               <a:t>حذف المجموعة وإعادة إنشائها</a:t>
             </a:r>
@@ -11314,6 +11743,8 @@
                   <a:srgbClr val="666666"/>
                 </a:solidFill>
                 <a:latin typeface="Calibri"/>
+                <a:cs typeface="Arial"/>
+                <a:ea typeface="Calibri"/>
               </a:rPr>
               <a:t>Drop &amp; recreate collection</a:t>
             </a:r>
@@ -11393,6 +11824,8 @@
                   <a:srgbClr val="333333"/>
                 </a:solidFill>
                 <a:latin typeface="Arial"/>
+                <a:cs typeface="Arial"/>
+                <a:ea typeface="Calibri"/>
               </a:rPr>
               <a:t>الترميز بدفعات (10)</a:t>
             </a:r>
@@ -11428,6 +11861,8 @@
                   <a:srgbClr val="666666"/>
                 </a:solidFill>
                 <a:latin typeface="Calibri"/>
+                <a:cs typeface="Arial"/>
+                <a:ea typeface="Calibri"/>
               </a:rPr>
               <a:t>Batched encoding (10)</a:t>
             </a:r>
@@ -11507,6 +11942,8 @@
                   <a:srgbClr val="333333"/>
                 </a:solidFill>
                 <a:latin typeface="Arial"/>
+                <a:cs typeface="Arial"/>
+                <a:ea typeface="Calibri"/>
               </a:rPr>
               <a:t>توجيه الطلبات بين النماذج</a:t>
             </a:r>
@@ -11542,6 +11979,8 @@
                   <a:srgbClr val="666666"/>
                 </a:solidFill>
                 <a:latin typeface="Calibri"/>
+                <a:cs typeface="Arial"/>
+                <a:ea typeface="Calibri"/>
               </a:rPr>
               <a:t>Model Routing</a:t>
             </a:r>
@@ -11621,6 +12060,8 @@
                   <a:srgbClr val="333333"/>
                 </a:solidFill>
                 <a:latin typeface="Arial"/>
+                <a:cs typeface="Arial"/>
+                <a:ea typeface="Calibri"/>
               </a:rPr>
               <a:t>التصنيف بمساعدة النموذج اللغوي</a:t>
             </a:r>
@@ -11656,6 +12097,8 @@
                   <a:srgbClr val="666666"/>
                 </a:solidFill>
                 <a:latin typeface="Calibri"/>
+                <a:cs typeface="Arial"/>
+                <a:ea typeface="Calibri"/>
               </a:rPr>
               <a:t>LLM-assisted Labeling</a:t>
             </a:r>
@@ -11761,6 +12204,8 @@
                   <a:srgbClr val="1F3B5C"/>
                 </a:solidFill>
                 <a:latin typeface="Arial"/>
+                <a:cs typeface="Arial"/>
+                <a:ea typeface="Calibri"/>
               </a:rPr>
               <a:t>المصطلحات (7) / Glossary</a:t>
             </a:r>
@@ -11796,6 +12241,8 @@
                   <a:srgbClr val="333333"/>
                 </a:solidFill>
                 <a:latin typeface="Arial"/>
+                <a:cs typeface="Arial"/>
+                <a:ea typeface="Calibri"/>
               </a:rPr>
               <a:t>التحقق البشري</a:t>
             </a:r>
@@ -11831,6 +12278,8 @@
                   <a:srgbClr val="666666"/>
                 </a:solidFill>
                 <a:latin typeface="Calibri"/>
+                <a:cs typeface="Arial"/>
+                <a:ea typeface="Calibri"/>
               </a:rPr>
               <a:t>Human-in-the-loop</a:t>
             </a:r>
@@ -11910,6 +12359,8 @@
                   <a:srgbClr val="333333"/>
                 </a:solidFill>
                 <a:latin typeface="Arial"/>
+                <a:cs typeface="Arial"/>
+                <a:ea typeface="Calibri"/>
               </a:rPr>
               <a:t>بوابة الذكاء الاصطناعي</a:t>
             </a:r>
@@ -11945,6 +12396,8 @@
                   <a:srgbClr val="666666"/>
                 </a:solidFill>
                 <a:latin typeface="Calibri"/>
+                <a:cs typeface="Arial"/>
+                <a:ea typeface="Calibri"/>
               </a:rPr>
               <a:t>AI Gateway</a:t>
             </a:r>
@@ -12024,6 +12477,8 @@
                   <a:srgbClr val="333333"/>
                 </a:solidFill>
                 <a:latin typeface="Arial"/>
+                <a:cs typeface="Arial"/>
+                <a:ea typeface="Calibri"/>
               </a:rPr>
               <a:t>مكتبة الموجِّهات</a:t>
             </a:r>
@@ -12059,6 +12514,8 @@
                   <a:srgbClr val="666666"/>
                 </a:solidFill>
                 <a:latin typeface="Calibri"/>
+                <a:cs typeface="Arial"/>
+                <a:ea typeface="Calibri"/>
               </a:rPr>
               <a:t>Prompt Library</a:t>
             </a:r>
@@ -12138,6 +12595,8 @@
                   <a:srgbClr val="333333"/>
                 </a:solidFill>
                 <a:latin typeface="Arial"/>
+                <a:cs typeface="Arial"/>
+                <a:ea typeface="Calibri"/>
               </a:rPr>
               <a:t>حواجز الحماية</a:t>
             </a:r>
@@ -12173,6 +12632,8 @@
                   <a:srgbClr val="666666"/>
                 </a:solidFill>
                 <a:latin typeface="Calibri"/>
+                <a:cs typeface="Arial"/>
+                <a:ea typeface="Calibri"/>
               </a:rPr>
               <a:t>Guardrails</a:t>
             </a:r>
@@ -12252,6 +12713,8 @@
                   <a:srgbClr val="333333"/>
                 </a:solidFill>
                 <a:latin typeface="Arial"/>
+                <a:cs typeface="Arial"/>
+                <a:ea typeface="Calibri"/>
               </a:rPr>
               <a:t>الذكاء الاصطناعي المسؤول</a:t>
             </a:r>
@@ -12287,6 +12750,8 @@
                   <a:srgbClr val="666666"/>
                 </a:solidFill>
                 <a:latin typeface="Calibri"/>
+                <a:cs typeface="Arial"/>
+                <a:ea typeface="Calibri"/>
               </a:rPr>
               <a:t>Responsible AI</a:t>
             </a:r>
@@ -12366,6 +12831,8 @@
                   <a:srgbClr val="333333"/>
                 </a:solidFill>
                 <a:latin typeface="Arial"/>
+                <a:cs typeface="Arial"/>
+                <a:ea typeface="Calibri"/>
               </a:rPr>
               <a:t>إدارة التكاليف السحابية</a:t>
             </a:r>
@@ -12401,6 +12868,8 @@
                   <a:srgbClr val="666666"/>
                 </a:solidFill>
                 <a:latin typeface="Calibri"/>
+                <a:cs typeface="Arial"/>
+                <a:ea typeface="Calibri"/>
               </a:rPr>
               <a:t>FinOps</a:t>
             </a:r>
@@ -12506,6 +12975,8 @@
                   <a:srgbClr val="1F3B5C"/>
                 </a:solidFill>
                 <a:latin typeface="Arial"/>
+                <a:cs typeface="Arial"/>
+                <a:ea typeface="Calibri"/>
               </a:rPr>
               <a:t>المصطلحات (8) / Glossary</a:t>
             </a:r>
@@ -12541,6 +13012,8 @@
                   <a:srgbClr val="333333"/>
                 </a:solidFill>
                 <a:latin typeface="Arial"/>
+                <a:cs typeface="Arial"/>
+                <a:ea typeface="Calibri"/>
               </a:rPr>
               <a:t>تتبع التجارب</a:t>
             </a:r>
@@ -12576,6 +13049,8 @@
                   <a:srgbClr val="666666"/>
                 </a:solidFill>
                 <a:latin typeface="Calibri"/>
+                <a:cs typeface="Arial"/>
+                <a:ea typeface="Calibri"/>
               </a:rPr>
               <a:t>Experiment Tracking</a:t>
             </a:r>
@@ -12655,6 +13130,8 @@
                   <a:srgbClr val="333333"/>
                 </a:solidFill>
                 <a:latin typeface="Arial"/>
+                <a:cs typeface="Arial"/>
+                <a:ea typeface="Calibri"/>
               </a:rPr>
               <a:t>إصدارات البيانات</a:t>
             </a:r>
@@ -12690,6 +13167,8 @@
                   <a:srgbClr val="666666"/>
                 </a:solidFill>
                 <a:latin typeface="Calibri"/>
+                <a:cs typeface="Arial"/>
+                <a:ea typeface="Calibri"/>
               </a:rPr>
               <a:t>Data Versioning</a:t>
             </a:r>

</xml_diff>